<commit_message>
KYC-Demo auf CIB seven, Doku auf Deutsch und Englisch
- Prozessdienst auf CIB seven 2.2 (Spring Boot) statt Kogito, Dashboard aus der Engine-Historie
- Weiterleitung /webapp/ auf den CIB seven Webclient
- Englische Fassungen aller Dokumente, Korrekturen in Quickstart und Trainingsergebnissen
- Präsentation: Engine-Folie und Notizen auf CIB seven umgestellt
- Eigenes Repository Vertical-Ai_CibSeven, Modell-Download aus dessen Release

Co-Authored-By: Claude Opus 5.5 <noreply@anthropic.com>
</commit_message>
<xml_diff>
--- a/praesentation/Vertical_AI_KYC.pptx
+++ b/praesentation/Vertical_AI_KYC.pptx
@@ -118,20 +118,20 @@
   <p:extLst>
     <p:ext uri="{521415D9-36F7-43E2-AB2F-B90AF26B5E84}">
       <p14:sectionLst xmlns:p14="http://schemas.microsoft.com/office/powerpoint/2010/main">
-        <p14:section name="Einstieg" id="{e257b48e-c2d1-a494-7bee-105dc74b46b3}">
+        <p14:section name="Einstieg" id="{c08b3833-07ae-f121-28f4-53cf8a102041}">
           <p14:sldIdLst>
             <p14:sldId id="256"/>
             <p14:sldId id="257"/>
           </p14:sldIdLst>
         </p14:section>
-        <p14:section name="Use Case und Prozess" id="{e2ea1be2-5bb0-53f1-7ca4-5bbc4bc5a06c}">
+        <p14:section name="Use Case und Prozess" id="{df86a483-327c-3d4e-63ca-ee67bfae99cd}">
           <p14:sldIdLst>
             <p14:sldId id="258"/>
             <p14:sldId id="259"/>
             <p14:sldId id="260"/>
           </p14:sldIdLst>
         </p14:section>
-        <p14:section name="Daten und Modell" id="{28483d0e-f409-b2e8-14b0-f55a9d311242}">
+        <p14:section name="Daten und Modell" id="{80adb06b-82df-48f1-4600-f333c3834a46}">
           <p14:sldIdLst>
             <p14:sldId id="261"/>
             <p14:sldId id="262"/>
@@ -139,13 +139,13 @@
             <p14:sldId id="264"/>
           </p14:sldIdLst>
         </p14:section>
-        <p14:section name="Demo" id="{94e01eba-3572-7b55-7069-b601055b66e9}">
+        <p14:section name="Demo" id="{fd1bc4bd-c5b9-e374-184c-1e3695a56844}">
           <p14:sldIdLst>
             <p14:sldId id="265"/>
             <p14:sldId id="266"/>
           </p14:sldIdLst>
         </p14:section>
-        <p14:section name="Abschluss" id="{4ce7df37-63c6-7fa9-9d50-15ffd2982d04}">
+        <p14:section name="Abschluss" id="{8d013432-3b80-ac5a-97ef-c6089366d2c9}">
           <p14:sldIdLst>
             <p14:sldId id="267"/>
           </p14:sldIdLst>
@@ -642,7 +642,7 @@
           <a:p>
             <a:r>
               <a:rPr lang="en-US" dirty="0"/>
-              <a:t>K01: automatische Freigabe. K11: Privatkonto mit geplanter Geschäftsnutzung – Laya schickt in die Prüfung. K06: Laya sagt ok, Regel R4 erzwingt die Prüfung. K15: bestätigter Sanktionstreffer, R5 lehnt sofort ab – Laya wird gar nicht gefragt. K13/K14: Karl (Wohnadresse Reeperbahn) gegen Marcin (nur Arbeitgeber an der Reeperbahn). Danach manuelle Prüfung im Postkorb und Ablauf im Dashboard. Weboberfläche: http://localhost:8080</a:t>
+              <a:t>K01: automatische Freigabe. K11: Privatkonto mit geplanter Geschäftsnutzung – Laya schickt in die Prüfung. K06: Laya sagt ok, Regel R4 erzwingt die Prüfung. K15: bestätigter Sanktionstreffer, R5 lehnt sofort ab – Laya wird gar nicht gefragt. K13/K14: Karl (Wohnadresse Reeperbahn) gegen Marcin (nur Arbeitgeber an der Reeperbahn). Danach manuelle Prüfung im Postkorb und Ablauf im Dashboard. Weboberfläche: http://localhost:8080. Dieselben Instanzen in den Werkzeugen von CIB seven: Cockpit (/camunda/app/cockpit/, demo/demo) mit DMN-Trefferzeilen, Tasklist (/camunda/app/tasklist/, anna/anna) mit derselben manuellen Prüfung.</a:t>
             </a:r>
             <a:endParaRPr lang="en-US" dirty="0"/>
           </a:p>
@@ -730,7 +730,7 @@
           <a:p>
             <a:r>
               <a:rPr lang="en-US" dirty="0"/>
-              <a:t>Die Demo läuft auf Kogito 10.2 (Apache KIE) als Quarkus-Microservice: BPMN-Prozess und DMN-Regeln werden beim Build zu Java-Code, jeder Prozess bekommt automatisch eine REST-API, der Dienst startet in Sekunden. Ideal, wenn ein Prozess als eigener Dienst in eine Microservice-Landschaft gehört. Grenze: Kogito bringt für User Tasks nur eine API mit. Postkorb, Prüfmaske und Dashboard der Demo haben wir selbst gebaut; Rechte, Vertretung und Betrieb fehlen. Für die Einbindung im Unternehmen mit vielen Sachbearbeitern empfehlen wir CIB flow: Low-Code-BPM-Plattform der CIB software GmbH mit Taskliste, Formularbaukasten (EasyForm), Rechteverwaltung, Dokumenten-Viewer und Konnektoren zu REST-APIs, on-premise oder als SaaS. Engine ist CIB seven, ein Fork von Camunda 7. Die Regeln (DMN) und das Laya-Modell lassen sich dort genauso über einen Service-Task anbinden.</a:t>
+              <a:t>Die Demo läuft auf CIB seven 2.2, dem Open-Source-Fork von Camunda 7, eingebettet in einen Spring-Boot-Dienst. BPMN und DMN werden beim Start deployt; die Regeln wertet die Engine selbst aus, Laya hängt per Service-Task über REST an. Cockpit und Tasklist kommen mit, die Historie der Engine speist unser Dashboard und dient als Prüfpfad. Grenze: Postkorb, Prüfmaske und Dashboard der Demo haben wir selbst gebaut; Formulare, Vertretung, Rechte und Betrieb für viele Sachbearbeiter fehlen. Dafür empfehlen wir CIB flow: Low-Code-BPM-Plattform der CIB software GmbH auf Basis von CIB seven mit Taskliste, Formularbaukasten (EasyForm), Rechteverwaltung, Dokumenten-Viewer und Konnektoren zu REST-APIs, on-premise oder als SaaS. Prozess, Regeln und Laya-Anbindung lassen sich unverändert übernehmen. Dieselbe Demo gibt es auch als Kogito-Microservice (Quarkus).</a:t>
             </a:r>
             <a:endParaRPr lang="en-US" dirty="0"/>
           </a:p>
@@ -1087,7 +1087,7 @@
           <a:p>
             <a:r>
               <a:rPr lang="en-US" dirty="0"/>
-              <a:t>Ablauf: Regeln (DMN) → Prüfung mit LLM (Laya) → Gateway → manuelle Prüfung → Freigabe oder Ablehnung. Automatische Freigabe nur bei grünen Regeln UND LLM-Entscheidung 'keine manuelle Prüfung'. Ein bestätigter Sanktionstreffer (R5) lehnt direkt am ersten Gateway ab, ohne LLM. Fällt Laya aus, geht der Fall in die manuelle Prüfung. Ausgeführt mit Kogito 10.2.</a:t>
+              <a:t>Ablauf: Regeln (DMN) → Prüfung mit LLM (Laya) → Gateway → manuelle Prüfung → Freigabe oder Ablehnung. Automatische Freigabe nur bei grünen Regeln UND LLM-Entscheidung 'keine manuelle Prüfung'. Ein bestätigter Sanktionstreffer (R5) lehnt direkt am ersten Gateway ab, ohne LLM. Fällt Laya aus, geht der Fall in die manuelle Prüfung. Ausgeführt mit CIB seven 2.2 (Spring Boot).</a:t>
             </a:r>
             <a:endParaRPr lang="en-US" dirty="0"/>
           </a:p>
@@ -1625,7 +1625,7 @@
       </p:grpSpPr>
       <p:pic>
         <p:nvPicPr>
-          <p:cNvPr id="2" name="Image 0" descr="/Users/mp/Documents/VSC-Projekte/Vorträge/Vertical AI/praesentation/assets/logo_piu.png">    </p:cNvPr>
+          <p:cNvPr id="2" name="Image 0" descr="/Users/mp/Documents/VSC-Projekte/Vorträge/Vertical AI CIB seven/praesentation/assets/logo_piu.png">    </p:cNvPr>
           <p:cNvPicPr>
             <a:picLocks noChangeAspect="1"/>
           </p:cNvPicPr>
@@ -1759,7 +1759,7 @@
       </p:grpSpPr>
       <p:pic>
         <p:nvPicPr>
-          <p:cNvPr id="2" name="Image 0" descr="/Users/mp/Documents/VSC-Projekte/Vorträge/Vertical AI/praesentation/assets/logo_piu.png">    </p:cNvPr>
+          <p:cNvPr id="2" name="Image 0" descr="/Users/mp/Documents/VSC-Projekte/Vorträge/Vertical AI CIB seven/praesentation/assets/logo_piu.png">    </p:cNvPr>
           <p:cNvPicPr>
             <a:picLocks noChangeAspect="1"/>
           </p:cNvPicPr>
@@ -3128,7 +3128,7 @@
                   <a:schemeClr val="tx1"/>
                 </a:solidFill>
               </a:rPr>
-              <a:t>Postkorb und Dashboard</a:t>
+              <a:t>Postkorb, Dashboard, Cockpit</a:t>
             </a:r>
             <a:endParaRPr lang="en-US" sz="1300" dirty="0"/>
           </a:p>
@@ -3285,7 +3285,7 @@
                   <a:schemeClr val="tx1"/>
                 </a:solidFill>
               </a:rPr>
-              <a:t>Die BPMN-Engine: Kogito und CIB flow</a:t>
+              <a:t>Die BPMN-Engine: CIB seven und CIB flow</a:t>
             </a:r>
             <a:endParaRPr lang="en-US" sz="3000" dirty="0"/>
           </a:p>
@@ -3293,7 +3293,7 @@
       </p:sp>
       <p:sp>
         <p:nvSpPr>
-          <p:cNvPr id="3" name="Engine Für Microservices"/>
+          <p:cNvPr id="3" name="Engine Die Engine der Demo"/>
           <p:cNvSpPr/>
           <p:nvPr/>
         </p:nvSpPr>
@@ -3320,7 +3320,7 @@
       </p:sp>
       <p:pic>
         <p:nvPicPr>
-          <p:cNvPr id="4" name="Logo Kogito" descr="Logo Kogito">    </p:cNvPr>
+          <p:cNvPr id="4" name="Logo CIB seven" descr="Logo CIB">    </p:cNvPr>
           <p:cNvPicPr>
             <a:picLocks noChangeAspect="1"/>
           </p:cNvPicPr>
@@ -3334,8 +3334,8 @@
         </p:blipFill>
         <p:spPr>
           <a:xfrm>
-            <a:off x="914400" y="1792321"/>
-            <a:ext cx="2377440" cy="667319"/>
+            <a:off x="914400" y="1763601"/>
+            <a:ext cx="1600200" cy="724757"/>
           </a:xfrm>
           <a:prstGeom prst="rect">
             <a:avLst/>
@@ -3344,7 +3344,43 @@
       </p:pic>
       <p:sp>
         <p:nvSpPr>
-          <p:cNvPr id="5" name="Einsatz Für Microservices"/>
+          <p:cNvPr id="5" name="Schriftzug seven"/>
+          <p:cNvSpPr txBox="1"/>
+          <p:nvPr/>
+        </p:nvSpPr>
+        <p:spPr>
+          <a:xfrm>
+            <a:off x="2651760" y="1783080"/>
+            <a:ext cx="1463040" cy="685800"/>
+          </a:xfrm>
+          <a:prstGeom prst="rect">
+            <a:avLst/>
+          </a:prstGeom>
+          <a:noFill/>
+          <a:ln/>
+        </p:spPr>
+        <p:txBody>
+          <a:bodyPr wrap="square" lIns="0" tIns="0" rIns="0" bIns="0" rtlCol="0" anchor="ctr"/>
+          <a:lstStyle/>
+          <a:p>
+            <a:pPr indent="0" marL="0">
+              <a:buNone/>
+            </a:pPr>
+            <a:r>
+              <a:rPr lang="en-US" sz="3000" b="1" dirty="0">
+                <a:solidFill>
+                  <a:schemeClr val="tx1"/>
+                </a:solidFill>
+              </a:rPr>
+              <a:t>seven</a:t>
+            </a:r>
+            <a:endParaRPr lang="en-US" sz="3000" dirty="0"/>
+          </a:p>
+        </p:txBody>
+      </p:sp>
+      <p:sp>
+        <p:nvSpPr>
+          <p:cNvPr id="6" name="Einsatz Die Engine der Demo"/>
           <p:cNvSpPr txBox="1"/>
           <p:nvPr/>
         </p:nvSpPr>
@@ -3372,7 +3408,7 @@
                   <a:schemeClr val="tx1"/>
                 </a:solidFill>
               </a:rPr>
-              <a:t>Für Microservices</a:t>
+              <a:t>Die Engine der Demo</a:t>
             </a:r>
             <a:endParaRPr lang="en-US" sz="2000" dirty="0"/>
           </a:p>
@@ -3380,7 +3416,7 @@
       </p:sp>
       <p:sp>
         <p:nvSpPr>
-          <p:cNvPr id="6" name="Merkmale Für Microservices"/>
+          <p:cNvPr id="7" name="Merkmale Die Engine der Demo"/>
           <p:cNvSpPr txBox="1"/>
           <p:nvPr/>
         </p:nvSpPr>
@@ -3412,7 +3448,7 @@
                   <a:schemeClr val="tx1"/>
                 </a:solidFill>
               </a:rPr>
-              <a:t>BPMN und DMN werden zu Java-Code</a:t>
+              <a:t>Open Source, Camunda-7-Fork</a:t>
             </a:r>
             <a:endParaRPr lang="en-US" sz="1500" dirty="0"/>
           </a:p>
@@ -3430,7 +3466,7 @@
                   <a:schemeClr val="tx1"/>
                 </a:solidFill>
               </a:rPr>
-              <a:t>Quarkus-Dienst mit REST-API je Prozess</a:t>
+              <a:t>Spring-Boot-Dienst mit REST-API</a:t>
             </a:r>
             <a:endParaRPr lang="en-US" sz="1500" dirty="0"/>
           </a:p>
@@ -3448,7 +3484,7 @@
                   <a:schemeClr val="tx1"/>
                 </a:solidFill>
               </a:rPr>
-              <a:t>Open Source, Apache KIE</a:t>
+              <a:t>DMN direkt in der Engine</a:t>
             </a:r>
             <a:endParaRPr lang="en-US" sz="1500" dirty="0"/>
           </a:p>
@@ -3466,7 +3502,7 @@
                   <a:schemeClr val="tx1"/>
                 </a:solidFill>
               </a:rPr>
-              <a:t>Superschnell</a:t>
+              <a:t>Cockpit und Tasklist inklusive</a:t>
             </a:r>
             <a:endParaRPr lang="en-US" sz="1500" dirty="0"/>
           </a:p>
@@ -3484,7 +3520,7 @@
                   <a:schemeClr val="tx1"/>
                 </a:solidFill>
               </a:rPr>
-              <a:t>100% testbar</a:t>
+              <a:t>Historie für Dashboard und Audit</a:t>
             </a:r>
             <a:endParaRPr lang="en-US" sz="1500" dirty="0"/>
           </a:p>
@@ -3492,7 +3528,7 @@
       </p:sp>
       <p:sp>
         <p:nvSpPr>
-          <p:cNvPr id="7" name="Engine Für die Enterprise-Einbindung"/>
+          <p:cNvPr id="8" name="Engine Für die Enterprise-Einbindung"/>
           <p:cNvSpPr/>
           <p:nvPr/>
         </p:nvSpPr>
@@ -3519,7 +3555,7 @@
       </p:sp>
       <p:pic>
         <p:nvPicPr>
-          <p:cNvPr id="8" name="Logo CIB flow" descr="Logo CIB">    </p:cNvPr>
+          <p:cNvPr id="9" name="Logo CIB flow" descr="Logo CIB">    </p:cNvPr>
           <p:cNvPicPr>
             <a:picLocks noChangeAspect="1"/>
           </p:cNvPicPr>
@@ -3543,7 +3579,7 @@
       </p:pic>
       <p:sp>
         <p:nvSpPr>
-          <p:cNvPr id="9" name="Schriftzug flow"/>
+          <p:cNvPr id="10" name="Schriftzug flow"/>
           <p:cNvSpPr txBox="1"/>
           <p:nvPr/>
         </p:nvSpPr>
@@ -3579,7 +3615,7 @@
       </p:sp>
       <p:sp>
         <p:nvSpPr>
-          <p:cNvPr id="10" name="Einsatz Für die Enterprise-Einbindung"/>
+          <p:cNvPr id="11" name="Einsatz Für die Enterprise-Einbindung"/>
           <p:cNvSpPr txBox="1"/>
           <p:nvPr/>
         </p:nvSpPr>
@@ -3615,7 +3651,7 @@
       </p:sp>
       <p:sp>
         <p:nvSpPr>
-          <p:cNvPr id="11" name="Merkmale Für die Enterprise-Einbindung"/>
+          <p:cNvPr id="12" name="Merkmale Für die Enterprise-Einbindung"/>
           <p:cNvSpPr txBox="1"/>
           <p:nvPr/>
         </p:nvSpPr>
@@ -3647,7 +3683,7 @@
                   <a:schemeClr val="tx1"/>
                 </a:solidFill>
               </a:rPr>
-              <a:t>Taskliste und Formulare für User Tasks</a:t>
+              <a:t>Formulare für User Tasks</a:t>
             </a:r>
             <a:endParaRPr lang="en-US" sz="1500" dirty="0"/>
           </a:p>
@@ -3683,7 +3719,7 @@
                   <a:schemeClr val="tx1"/>
                 </a:solidFill>
               </a:rPr>
-              <a:t>Engine CIB seven (Camunda-7-Fork)</a:t>
+              <a:t>Baut auf CIB seven auf</a:t>
             </a:r>
             <a:endParaRPr lang="en-US" sz="1500" dirty="0"/>
           </a:p>
@@ -3691,7 +3727,7 @@
       </p:sp>
       <p:sp>
         <p:nvSpPr>
-          <p:cNvPr id="12" name="Zitatbalken"/>
+          <p:cNvPr id="13" name="Zitatbalken"/>
           <p:cNvSpPr/>
           <p:nvPr/>
         </p:nvSpPr>
@@ -3716,7 +3752,7 @@
       </p:sp>
       <p:sp>
         <p:nvSpPr>
-          <p:cNvPr id="13" name="Empfehlung"/>
+          <p:cNvPr id="14" name="Empfehlung"/>
           <p:cNvSpPr txBox="1"/>
           <p:nvPr/>
         </p:nvSpPr>
@@ -3744,7 +3780,7 @@
                   <a:schemeClr val="tx1"/>
                 </a:solidFill>
               </a:rPr>
-              <a:t>Kogito für Microservices – für die Enterprise-Einbindung mit User Tasks empfehlen wir CIB flow.</a:t>
+              <a:t>Die Demo läuft auf CIB seven – für viele Sachbearbeiter mit Formularen und Rechten empfehlen wir CIB flow.</a:t>
             </a:r>
             <a:endParaRPr lang="en-US" sz="1600" dirty="0"/>
           </a:p>

</xml_diff>